<commit_message>
Added slides for graph data structure
</commit_message>
<xml_diff>
--- a/graph/Graph.pptx
+++ b/graph/Graph.pptx
@@ -8044,8 +8044,8 @@
           </a:p>
         </p:txBody>
       </p:sp>
-      <mc:AlternateContent xmlns:mc="http://schemas.openxmlformats.org/markup-compatibility/2006">
-        <mc:Choice xmlns:a14="http://schemas.microsoft.com/office/drawing/2010/main" Requires="a14">
+      <mc:AlternateContent xmlns:mc="http://schemas.openxmlformats.org/markup-compatibility/2006" xmlns:a14="http://schemas.microsoft.com/office/drawing/2010/main">
+        <mc:Choice Requires="a14">
           <p:sp>
             <p:nvSpPr>
               <p:cNvPr id="2" name="TextBox 1">
@@ -8366,7 +8366,7 @@
             </p:txBody>
           </p:sp>
         </mc:Choice>
-        <mc:Fallback>
+        <mc:Fallback xmlns="">
           <p:sp>
             <p:nvSpPr>
               <p:cNvPr id="2" name="TextBox 1">
@@ -8416,8 +8416,8 @@
           </p:sp>
         </mc:Fallback>
       </mc:AlternateContent>
-      <mc:AlternateContent xmlns:mc="http://schemas.openxmlformats.org/markup-compatibility/2006">
-        <mc:Choice xmlns:a14="http://schemas.microsoft.com/office/drawing/2010/main" Requires="a14">
+      <mc:AlternateContent xmlns:mc="http://schemas.openxmlformats.org/markup-compatibility/2006" xmlns:a14="http://schemas.microsoft.com/office/drawing/2010/main">
+        <mc:Choice Requires="a14">
           <p:sp>
             <p:nvSpPr>
               <p:cNvPr id="3" name="TextBox 2">
@@ -8578,7 +8578,7 @@
             </p:txBody>
           </p:sp>
         </mc:Choice>
-        <mc:Fallback>
+        <mc:Fallback xmlns="">
           <p:sp>
             <p:nvSpPr>
               <p:cNvPr id="3" name="TextBox 2">
@@ -9123,13 +9123,13 @@
   <p:clrMapOvr>
     <a:masterClrMapping/>
   </p:clrMapOvr>
-  <mc:AlternateContent xmlns:mc="http://schemas.openxmlformats.org/markup-compatibility/2006">
-    <mc:Choice xmlns:p159="http://schemas.microsoft.com/office/powerpoint/2015/09/main" Requires="p159">
+  <mc:AlternateContent xmlns:mc="http://schemas.openxmlformats.org/markup-compatibility/2006" xmlns:p159="http://schemas.microsoft.com/office/powerpoint/2015/09/main">
+    <mc:Choice Requires="p159">
       <p:transition xmlns:p14="http://schemas.microsoft.com/office/powerpoint/2010/main" spd="slow" p14:dur="2000">
         <p159:morph option="byObject"/>
       </p:transition>
     </mc:Choice>
-    <mc:Fallback>
+    <mc:Fallback xmlns="">
       <p:transition spd="slow">
         <p:fade/>
       </p:transition>
@@ -10557,8 +10557,8 @@
           </a:fontRef>
         </p:style>
       </p:cxnSp>
-      <mc:AlternateContent xmlns:mc="http://schemas.openxmlformats.org/markup-compatibility/2006">
-        <mc:Choice xmlns:a14="http://schemas.microsoft.com/office/drawing/2010/main" Requires="a14">
+      <mc:AlternateContent xmlns:mc="http://schemas.openxmlformats.org/markup-compatibility/2006" xmlns:a14="http://schemas.microsoft.com/office/drawing/2010/main">
+        <mc:Choice Requires="a14">
           <p:sp>
             <p:nvSpPr>
               <p:cNvPr id="2" name="TextBox 1">
@@ -10983,7 +10983,7 @@
             </p:txBody>
           </p:sp>
         </mc:Choice>
-        <mc:Fallback>
+        <mc:Fallback xmlns="">
           <p:sp>
             <p:nvSpPr>
               <p:cNvPr id="2" name="TextBox 1">
@@ -11033,8 +11033,8 @@
           </p:sp>
         </mc:Fallback>
       </mc:AlternateContent>
-      <mc:AlternateContent xmlns:mc="http://schemas.openxmlformats.org/markup-compatibility/2006">
-        <mc:Choice xmlns:a14="http://schemas.microsoft.com/office/drawing/2010/main" Requires="a14">
+      <mc:AlternateContent xmlns:mc="http://schemas.openxmlformats.org/markup-compatibility/2006" xmlns:a14="http://schemas.microsoft.com/office/drawing/2010/main">
+        <mc:Choice Requires="a14">
           <p:sp>
             <p:nvSpPr>
               <p:cNvPr id="3" name="TextBox 2">
@@ -11195,7 +11195,7 @@
             </p:txBody>
           </p:sp>
         </mc:Choice>
-        <mc:Fallback>
+        <mc:Fallback xmlns="">
           <p:sp>
             <p:nvSpPr>
               <p:cNvPr id="3" name="TextBox 2">
@@ -11255,13 +11255,13 @@
   <p:clrMapOvr>
     <a:masterClrMapping/>
   </p:clrMapOvr>
-  <mc:AlternateContent xmlns:mc="http://schemas.openxmlformats.org/markup-compatibility/2006">
-    <mc:Choice xmlns:p159="http://schemas.microsoft.com/office/powerpoint/2015/09/main" Requires="p159">
+  <mc:AlternateContent xmlns:mc="http://schemas.openxmlformats.org/markup-compatibility/2006" xmlns:p159="http://schemas.microsoft.com/office/powerpoint/2015/09/main">
+    <mc:Choice Requires="p159">
       <p:transition xmlns:p14="http://schemas.microsoft.com/office/powerpoint/2010/main" spd="slow" p14:dur="2000">
         <p159:morph option="byObject"/>
       </p:transition>
     </mc:Choice>
-    <mc:Fallback>
+    <mc:Fallback xmlns="">
       <p:transition spd="slow">
         <p:fade/>
       </p:transition>
@@ -12052,7 +12052,7 @@
                   <a:schemeClr val="bg1"/>
                 </a:solidFill>
               </a:rPr>
-              <a:t>9</a:t>
+              <a:t>2</a:t>
             </a:r>
             <a:endParaRPr lang="en-US" sz="2500" dirty="0">
               <a:solidFill>
@@ -14057,59 +14057,6 @@
       </p:sp>
       <p:sp>
         <p:nvSpPr>
-          <p:cNvPr id="4" name="TextBox 3">
-            <a:extLst>
-              <a:ext uri="{FF2B5EF4-FFF2-40B4-BE49-F238E27FC236}">
-                <a16:creationId xmlns:a16="http://schemas.microsoft.com/office/drawing/2014/main" id="{804E3A1B-C4EA-1E67-4D41-63B0DD2399DA}"/>
-              </a:ext>
-            </a:extLst>
-          </p:cNvPr>
-          <p:cNvSpPr txBox="1"/>
-          <p:nvPr/>
-        </p:nvSpPr>
-        <p:spPr>
-          <a:xfrm>
-            <a:off x="609600" y="5469819"/>
-            <a:ext cx="10972800" cy="477054"/>
-          </a:xfrm>
-          <a:prstGeom prst="rect">
-            <a:avLst/>
-          </a:prstGeom>
-          <a:noFill/>
-        </p:spPr>
-        <p:txBody>
-          <a:bodyPr wrap="square">
-            <a:spAutoFit/>
-          </a:bodyPr>
-          <a:lstStyle/>
-          <a:p>
-            <a:pPr algn="ctr"/>
-            <a:r>
-              <a:rPr lang="en-PH" sz="2500" dirty="0">
-                <a:solidFill>
-                  <a:schemeClr val="bg1"/>
-                </a:solidFill>
-              </a:rPr>
-              <a:t>When the edges is assigned some value which is </a:t>
-            </a:r>
-            <a:r>
-              <a:rPr lang="en-PH" sz="2500" b="1" dirty="0">
-                <a:solidFill>
-                  <a:schemeClr val="bg1"/>
-                </a:solidFill>
-              </a:rPr>
-              <a:t>greater than or equal to zero</a:t>
-            </a:r>
-            <a:endParaRPr lang="en-US" sz="2500" b="1" dirty="0">
-              <a:solidFill>
-                <a:schemeClr val="bg1"/>
-              </a:solidFill>
-            </a:endParaRPr>
-          </a:p>
-        </p:txBody>
-      </p:sp>
-      <p:sp>
-        <p:nvSpPr>
           <p:cNvPr id="7" name="Oval 6">
             <a:extLst>
               <a:ext uri="{FF2B5EF4-FFF2-40B4-BE49-F238E27FC236}">
@@ -18921,7 +18868,7 @@
                 </a:solidFill>
                 <a:effectLst/>
               </a:rPr>
-              <a:t>Connected Graph</a:t>
+              <a:t>Complete Graph</a:t>
             </a:r>
             <a:endParaRPr lang="en-PH" dirty="0">
               <a:solidFill>
@@ -18982,7 +18929,7 @@
                   <a:schemeClr val="bg1"/>
                 </a:solidFill>
               </a:rPr>
-              <a:t>is a graph in which all nodes are is directly connected to every other node.</a:t>
+              <a:t>is a graph in which all nodes are directly connected to every other node.</a:t>
             </a:r>
             <a:endParaRPr lang="en-US" sz="2500" dirty="0">
               <a:solidFill>
@@ -18994,10 +18941,10 @@
       </p:sp>
       <p:sp>
         <p:nvSpPr>
-          <p:cNvPr id="7" name="Oval 6">
-            <a:extLst>
-              <a:ext uri="{FF2B5EF4-FFF2-40B4-BE49-F238E27FC236}">
-                <a16:creationId xmlns:a16="http://schemas.microsoft.com/office/drawing/2014/main" id="{A5A1A53C-E2F7-232D-9553-BF51A54897AA}"/>
+          <p:cNvPr id="29" name="Oval 28">
+            <a:extLst>
+              <a:ext uri="{FF2B5EF4-FFF2-40B4-BE49-F238E27FC236}">
+                <a16:creationId xmlns:a16="http://schemas.microsoft.com/office/drawing/2014/main" id="{DEF69A8C-3194-4AD5-C4CA-9BEA97F24CD4}"/>
               </a:ext>
             </a:extLst>
           </p:cNvPr>
@@ -19006,7 +18953,7 @@
         </p:nvSpPr>
         <p:spPr>
           <a:xfrm>
-            <a:off x="4406496" y="1703749"/>
+            <a:off x="4472342" y="1703749"/>
             <a:ext cx="720000" cy="720000"/>
           </a:xfrm>
           <a:prstGeom prst="ellipse">
@@ -19046,10 +18993,10 @@
       </p:sp>
       <p:sp>
         <p:nvSpPr>
-          <p:cNvPr id="8" name="Oval 7">
-            <a:extLst>
-              <a:ext uri="{FF2B5EF4-FFF2-40B4-BE49-F238E27FC236}">
-                <a16:creationId xmlns:a16="http://schemas.microsoft.com/office/drawing/2014/main" id="{B8BD8BA9-1989-59E1-20BE-AA1E6E52A1B7}"/>
+          <p:cNvPr id="30" name="Oval 29">
+            <a:extLst>
+              <a:ext uri="{FF2B5EF4-FFF2-40B4-BE49-F238E27FC236}">
+                <a16:creationId xmlns:a16="http://schemas.microsoft.com/office/drawing/2014/main" id="{A1A4FD6F-C67A-1DD1-B1D2-86FC7A0A805B}"/>
               </a:ext>
             </a:extLst>
           </p:cNvPr>
@@ -19058,7 +19005,7 @@
         </p:nvSpPr>
         <p:spPr>
           <a:xfrm>
-            <a:off x="6773377" y="3828119"/>
+            <a:off x="6839223" y="3828119"/>
             <a:ext cx="720000" cy="720000"/>
           </a:xfrm>
           <a:prstGeom prst="ellipse">
@@ -19098,23 +19045,23 @@
       </p:sp>
       <p:cxnSp>
         <p:nvCxnSpPr>
-          <p:cNvPr id="9" name="Straight Connector 8">
-            <a:extLst>
-              <a:ext uri="{FF2B5EF4-FFF2-40B4-BE49-F238E27FC236}">
-                <a16:creationId xmlns:a16="http://schemas.microsoft.com/office/drawing/2014/main" id="{C64DB775-311D-72C0-45B7-0970DCCEF19C}"/>
+          <p:cNvPr id="31" name="Straight Connector 30">
+            <a:extLst>
+              <a:ext uri="{FF2B5EF4-FFF2-40B4-BE49-F238E27FC236}">
+                <a16:creationId xmlns:a16="http://schemas.microsoft.com/office/drawing/2014/main" id="{B7C19BC7-D115-8FD0-271D-36C85C13AA76}"/>
               </a:ext>
             </a:extLst>
           </p:cNvPr>
           <p:cNvCxnSpPr>
             <a:cxnSpLocks/>
-            <a:stCxn id="11" idx="0"/>
-            <a:endCxn id="7" idx="4"/>
+            <a:stCxn id="32" idx="0"/>
+            <a:endCxn id="29" idx="4"/>
           </p:cNvCxnSpPr>
           <p:nvPr/>
         </p:nvCxnSpPr>
         <p:spPr>
           <a:xfrm flipV="1">
-            <a:off x="4766496" y="2423749"/>
+            <a:off x="4832342" y="2423749"/>
             <a:ext cx="0" cy="1404370"/>
           </a:xfrm>
           <a:prstGeom prst="line">
@@ -19143,10 +19090,10 @@
       </p:cxnSp>
       <p:sp>
         <p:nvSpPr>
-          <p:cNvPr id="11" name="Oval 10">
-            <a:extLst>
-              <a:ext uri="{FF2B5EF4-FFF2-40B4-BE49-F238E27FC236}">
-                <a16:creationId xmlns:a16="http://schemas.microsoft.com/office/drawing/2014/main" id="{35793C5D-BE43-657F-552C-4541A69DE9D3}"/>
+          <p:cNvPr id="32" name="Oval 31">
+            <a:extLst>
+              <a:ext uri="{FF2B5EF4-FFF2-40B4-BE49-F238E27FC236}">
+                <a16:creationId xmlns:a16="http://schemas.microsoft.com/office/drawing/2014/main" id="{E5B71A37-D58E-A94D-446E-E4C0C1AE74C4}"/>
               </a:ext>
             </a:extLst>
           </p:cNvPr>
@@ -19155,7 +19102,7 @@
         </p:nvSpPr>
         <p:spPr>
           <a:xfrm>
-            <a:off x="4406496" y="3828119"/>
+            <a:off x="4472342" y="3828119"/>
             <a:ext cx="720000" cy="720000"/>
           </a:xfrm>
           <a:prstGeom prst="ellipse">
@@ -19195,23 +19142,23 @@
       </p:sp>
       <p:cxnSp>
         <p:nvCxnSpPr>
-          <p:cNvPr id="13" name="Straight Connector 12">
-            <a:extLst>
-              <a:ext uri="{FF2B5EF4-FFF2-40B4-BE49-F238E27FC236}">
-                <a16:creationId xmlns:a16="http://schemas.microsoft.com/office/drawing/2014/main" id="{D61D07D4-116D-6DE2-45A1-73A3A69D0202}"/>
+          <p:cNvPr id="33" name="Straight Connector 32">
+            <a:extLst>
+              <a:ext uri="{FF2B5EF4-FFF2-40B4-BE49-F238E27FC236}">
+                <a16:creationId xmlns:a16="http://schemas.microsoft.com/office/drawing/2014/main" id="{A93CE12E-0BAA-5C07-4C32-F23574384F2C}"/>
               </a:ext>
             </a:extLst>
           </p:cNvPr>
           <p:cNvCxnSpPr>
             <a:cxnSpLocks/>
-            <a:stCxn id="11" idx="6"/>
-            <a:endCxn id="8" idx="2"/>
+            <a:stCxn id="32" idx="6"/>
+            <a:endCxn id="30" idx="2"/>
           </p:cNvCxnSpPr>
           <p:nvPr/>
         </p:nvCxnSpPr>
         <p:spPr>
           <a:xfrm>
-            <a:off x="5126496" y="4188119"/>
+            <a:off x="5192342" y="4188119"/>
             <a:ext cx="1646881" cy="0"/>
           </a:xfrm>
           <a:prstGeom prst="line">
@@ -19240,10 +19187,10 @@
       </p:cxnSp>
       <p:sp>
         <p:nvSpPr>
-          <p:cNvPr id="15" name="Oval 14">
-            <a:extLst>
-              <a:ext uri="{FF2B5EF4-FFF2-40B4-BE49-F238E27FC236}">
-                <a16:creationId xmlns:a16="http://schemas.microsoft.com/office/drawing/2014/main" id="{1B792AB0-7529-2EBF-D5BC-28E65AEFD378}"/>
+          <p:cNvPr id="34" name="Oval 33">
+            <a:extLst>
+              <a:ext uri="{FF2B5EF4-FFF2-40B4-BE49-F238E27FC236}">
+                <a16:creationId xmlns:a16="http://schemas.microsoft.com/office/drawing/2014/main" id="{A0C45DFB-09F7-16A2-DEFD-B18F455C68A1}"/>
               </a:ext>
             </a:extLst>
           </p:cNvPr>
@@ -19252,7 +19199,7 @@
         </p:nvSpPr>
         <p:spPr>
           <a:xfrm>
-            <a:off x="6773377" y="1703749"/>
+            <a:off x="6839223" y="1703749"/>
             <a:ext cx="720000" cy="720000"/>
           </a:xfrm>
           <a:prstGeom prst="ellipse">
@@ -19292,121 +19239,24 @@
       </p:sp>
       <p:cxnSp>
         <p:nvCxnSpPr>
-          <p:cNvPr id="17" name="Straight Connector 16">
-            <a:extLst>
-              <a:ext uri="{FF2B5EF4-FFF2-40B4-BE49-F238E27FC236}">
-                <a16:creationId xmlns:a16="http://schemas.microsoft.com/office/drawing/2014/main" id="{7BC92986-9F79-EECA-AAF4-8F1B8D56E55B}"/>
+          <p:cNvPr id="35" name="Straight Connector 34">
+            <a:extLst>
+              <a:ext uri="{FF2B5EF4-FFF2-40B4-BE49-F238E27FC236}">
+                <a16:creationId xmlns:a16="http://schemas.microsoft.com/office/drawing/2014/main" id="{9E4ECDEB-71E7-45DB-85AC-7419A183BCB2}"/>
               </a:ext>
             </a:extLst>
           </p:cNvPr>
           <p:cNvCxnSpPr>
             <a:cxnSpLocks/>
-            <a:stCxn id="15" idx="2"/>
-            <a:endCxn id="7" idx="6"/>
+            <a:stCxn id="34" idx="2"/>
+            <a:endCxn id="29" idx="6"/>
           </p:cNvCxnSpPr>
           <p:nvPr/>
         </p:nvCxnSpPr>
         <p:spPr>
           <a:xfrm flipH="1">
-            <a:off x="5126496" y="2063749"/>
+            <a:off x="5192342" y="2063749"/>
             <a:ext cx="1646881" cy="0"/>
-          </a:xfrm>
-          <a:prstGeom prst="line">
-            <a:avLst/>
-          </a:prstGeom>
-          <a:ln w="38100">
-            <a:solidFill>
-              <a:srgbClr val="AAAAAA"/>
-            </a:solidFill>
-          </a:ln>
-        </p:spPr>
-        <p:style>
-          <a:lnRef idx="1">
-            <a:schemeClr val="accent1"/>
-          </a:lnRef>
-          <a:fillRef idx="0">
-            <a:schemeClr val="accent1"/>
-          </a:fillRef>
-          <a:effectRef idx="0">
-            <a:schemeClr val="accent1"/>
-          </a:effectRef>
-          <a:fontRef idx="minor">
-            <a:schemeClr val="tx1"/>
-          </a:fontRef>
-        </p:style>
-      </p:cxnSp>
-      <p:sp>
-        <p:nvSpPr>
-          <p:cNvPr id="18" name="Oval 17">
-            <a:extLst>
-              <a:ext uri="{FF2B5EF4-FFF2-40B4-BE49-F238E27FC236}">
-                <a16:creationId xmlns:a16="http://schemas.microsoft.com/office/drawing/2014/main" id="{6E8848A0-7CAF-A0A8-2351-53124843933C}"/>
-              </a:ext>
-            </a:extLst>
-          </p:cNvPr>
-          <p:cNvSpPr/>
-          <p:nvPr/>
-        </p:nvSpPr>
-        <p:spPr>
-          <a:xfrm>
-            <a:off x="5609470" y="2765934"/>
-            <a:ext cx="720000" cy="720000"/>
-          </a:xfrm>
-          <a:prstGeom prst="ellipse">
-            <a:avLst/>
-          </a:prstGeom>
-          <a:solidFill>
-            <a:srgbClr val="6AB5FF"/>
-          </a:solidFill>
-        </p:spPr>
-        <p:style>
-          <a:lnRef idx="2">
-            <a:schemeClr val="accent1">
-              <a:shade val="15000"/>
-            </a:schemeClr>
-          </a:lnRef>
-          <a:fillRef idx="1">
-            <a:schemeClr val="accent1"/>
-          </a:fillRef>
-          <a:effectRef idx="0">
-            <a:schemeClr val="accent1"/>
-          </a:effectRef>
-          <a:fontRef idx="minor">
-            <a:schemeClr val="lt1"/>
-          </a:fontRef>
-        </p:style>
-        <p:txBody>
-          <a:bodyPr rtlCol="0" anchor="ctr"/>
-          <a:lstStyle/>
-          <a:p>
-            <a:pPr algn="ctr"/>
-            <a:r>
-              <a:rPr lang="en-US" sz="4000" b="1" dirty="0"/>
-              <a:t>e</a:t>
-            </a:r>
-          </a:p>
-        </p:txBody>
-      </p:sp>
-      <p:cxnSp>
-        <p:nvCxnSpPr>
-          <p:cNvPr id="19" name="Straight Connector 18">
-            <a:extLst>
-              <a:ext uri="{FF2B5EF4-FFF2-40B4-BE49-F238E27FC236}">
-                <a16:creationId xmlns:a16="http://schemas.microsoft.com/office/drawing/2014/main" id="{9731DEFA-F6F1-B29F-798D-C8C308826D8A}"/>
-              </a:ext>
-            </a:extLst>
-          </p:cNvPr>
-          <p:cNvCxnSpPr>
-            <a:cxnSpLocks/>
-            <a:stCxn id="15" idx="4"/>
-            <a:endCxn id="8" idx="0"/>
-          </p:cNvCxnSpPr>
-          <p:nvPr/>
-        </p:nvCxnSpPr>
-        <p:spPr>
-          <a:xfrm>
-            <a:off x="7133377" y="2423749"/>
-            <a:ext cx="0" cy="1404370"/>
           </a:xfrm>
           <a:prstGeom prst="line">
             <a:avLst/>
@@ -19434,24 +19284,24 @@
       </p:cxnSp>
       <p:cxnSp>
         <p:nvCxnSpPr>
-          <p:cNvPr id="44" name="Straight Connector 43">
-            <a:extLst>
-              <a:ext uri="{FF2B5EF4-FFF2-40B4-BE49-F238E27FC236}">
-                <a16:creationId xmlns:a16="http://schemas.microsoft.com/office/drawing/2014/main" id="{E9B1CF7A-7493-8134-4192-9DD712452339}"/>
+          <p:cNvPr id="37" name="Straight Connector 36">
+            <a:extLst>
+              <a:ext uri="{FF2B5EF4-FFF2-40B4-BE49-F238E27FC236}">
+                <a16:creationId xmlns:a16="http://schemas.microsoft.com/office/drawing/2014/main" id="{24C8B4FE-F444-81CD-07DA-F8CC0E36225E}"/>
               </a:ext>
             </a:extLst>
           </p:cNvPr>
           <p:cNvCxnSpPr>
             <a:cxnSpLocks/>
-            <a:stCxn id="18" idx="5"/>
-            <a:endCxn id="8" idx="1"/>
+            <a:stCxn id="34" idx="4"/>
+            <a:endCxn id="30" idx="0"/>
           </p:cNvCxnSpPr>
           <p:nvPr/>
         </p:nvCxnSpPr>
         <p:spPr>
           <a:xfrm>
-            <a:off x="6224028" y="3380492"/>
-            <a:ext cx="654791" cy="553069"/>
+            <a:off x="7199223" y="2423749"/>
+            <a:ext cx="0" cy="1404370"/>
           </a:xfrm>
           <a:prstGeom prst="line">
             <a:avLst/>
@@ -19479,24 +19329,24 @@
       </p:cxnSp>
       <p:cxnSp>
         <p:nvCxnSpPr>
-          <p:cNvPr id="10" name="Straight Connector 9">
-            <a:extLst>
-              <a:ext uri="{FF2B5EF4-FFF2-40B4-BE49-F238E27FC236}">
-                <a16:creationId xmlns:a16="http://schemas.microsoft.com/office/drawing/2014/main" id="{32ABC491-0B60-2B51-C0B9-5AEED6F8BAE4}"/>
+          <p:cNvPr id="38" name="Straight Connector 37">
+            <a:extLst>
+              <a:ext uri="{FF2B5EF4-FFF2-40B4-BE49-F238E27FC236}">
+                <a16:creationId xmlns:a16="http://schemas.microsoft.com/office/drawing/2014/main" id="{AD6FCD35-CA96-F2D3-3656-2DD69D276DD4}"/>
               </a:ext>
             </a:extLst>
           </p:cNvPr>
           <p:cNvCxnSpPr>
             <a:cxnSpLocks/>
-            <a:stCxn id="7" idx="5"/>
-            <a:endCxn id="18" idx="1"/>
+            <a:stCxn id="29" idx="5"/>
+            <a:endCxn id="30" idx="1"/>
           </p:cNvCxnSpPr>
           <p:nvPr/>
         </p:nvCxnSpPr>
         <p:spPr>
           <a:xfrm>
-            <a:off x="5021054" y="2318307"/>
-            <a:ext cx="693858" cy="553069"/>
+            <a:off x="5086900" y="2318307"/>
+            <a:ext cx="1857765" cy="1615254"/>
           </a:xfrm>
           <a:prstGeom prst="line">
             <a:avLst/>
@@ -19524,69 +19374,24 @@
       </p:cxnSp>
       <p:cxnSp>
         <p:nvCxnSpPr>
-          <p:cNvPr id="16" name="Straight Connector 15">
-            <a:extLst>
-              <a:ext uri="{FF2B5EF4-FFF2-40B4-BE49-F238E27FC236}">
-                <a16:creationId xmlns:a16="http://schemas.microsoft.com/office/drawing/2014/main" id="{BBD8889B-F6F8-99D3-53D6-29D6B2C3EE1E}"/>
+          <p:cNvPr id="41" name="Straight Connector 40">
+            <a:extLst>
+              <a:ext uri="{FF2B5EF4-FFF2-40B4-BE49-F238E27FC236}">
+                <a16:creationId xmlns:a16="http://schemas.microsoft.com/office/drawing/2014/main" id="{0DC96C33-73BC-829F-E49F-51EB7271511C}"/>
               </a:ext>
             </a:extLst>
           </p:cNvPr>
           <p:cNvCxnSpPr>
             <a:cxnSpLocks/>
-            <a:stCxn id="11" idx="7"/>
-            <a:endCxn id="18" idx="3"/>
+            <a:stCxn id="32" idx="7"/>
+            <a:endCxn id="34" idx="3"/>
           </p:cNvCxnSpPr>
           <p:nvPr/>
         </p:nvCxnSpPr>
         <p:spPr>
           <a:xfrm flipV="1">
-            <a:off x="5021054" y="3380492"/>
-            <a:ext cx="693858" cy="553069"/>
-          </a:xfrm>
-          <a:prstGeom prst="line">
-            <a:avLst/>
-          </a:prstGeom>
-          <a:ln w="38100">
-            <a:solidFill>
-              <a:srgbClr val="AAAAAA"/>
-            </a:solidFill>
-          </a:ln>
-        </p:spPr>
-        <p:style>
-          <a:lnRef idx="1">
-            <a:schemeClr val="accent1"/>
-          </a:lnRef>
-          <a:fillRef idx="0">
-            <a:schemeClr val="accent1"/>
-          </a:fillRef>
-          <a:effectRef idx="0">
-            <a:schemeClr val="accent1"/>
-          </a:effectRef>
-          <a:fontRef idx="minor">
-            <a:schemeClr val="tx1"/>
-          </a:fontRef>
-        </p:style>
-      </p:cxnSp>
-      <p:cxnSp>
-        <p:nvCxnSpPr>
-          <p:cNvPr id="2" name="Straight Connector 1">
-            <a:extLst>
-              <a:ext uri="{FF2B5EF4-FFF2-40B4-BE49-F238E27FC236}">
-                <a16:creationId xmlns:a16="http://schemas.microsoft.com/office/drawing/2014/main" id="{E2AF2744-49B9-C7AB-614A-C751DD2520F1}"/>
-              </a:ext>
-            </a:extLst>
-          </p:cNvPr>
-          <p:cNvCxnSpPr>
-            <a:cxnSpLocks/>
-            <a:stCxn id="18" idx="7"/>
-            <a:endCxn id="15" idx="3"/>
-          </p:cNvCxnSpPr>
-          <p:nvPr/>
-        </p:nvCxnSpPr>
-        <p:spPr>
-          <a:xfrm flipV="1">
-            <a:off x="6224028" y="2318307"/>
-            <a:ext cx="654791" cy="553069"/>
+            <a:off x="5086900" y="2318307"/>
+            <a:ext cx="1857765" cy="1615254"/>
           </a:xfrm>
           <a:prstGeom prst="line">
             <a:avLst/>
@@ -20559,7 +20364,7 @@
                   <a:schemeClr val="bg1"/>
                 </a:solidFill>
               </a:rPr>
-              <a:t>is the total number of edges coming to that node</a:t>
+              <a:t>is the total number of edges coming out of that node</a:t>
             </a:r>
             <a:endParaRPr lang="en-US" sz="2500" dirty="0">
               <a:solidFill>
@@ -28829,13 +28634,13 @@
   <p:clrMapOvr>
     <a:masterClrMapping/>
   </p:clrMapOvr>
-  <mc:AlternateContent xmlns:mc="http://schemas.openxmlformats.org/markup-compatibility/2006">
-    <mc:Choice xmlns:p159="http://schemas.microsoft.com/office/powerpoint/2015/09/main" Requires="p159">
+  <mc:AlternateContent xmlns:mc="http://schemas.openxmlformats.org/markup-compatibility/2006" xmlns:p159="http://schemas.microsoft.com/office/powerpoint/2015/09/main">
+    <mc:Choice Requires="p159">
       <p:transition xmlns:p14="http://schemas.microsoft.com/office/powerpoint/2010/main" spd="slow" p14:dur="2000">
         <p159:morph option="byObject"/>
       </p:transition>
     </mc:Choice>
-    <mc:Fallback>
+    <mc:Fallback xmlns="">
       <p:transition spd="slow">
         <p:fade/>
       </p:transition>
@@ -28904,13 +28709,13 @@
           <a:lstStyle/>
           <a:p>
             <a:r>
-              <a:rPr lang="en-US" sz="6000" b="1" i="0" dirty="0">
+              <a:rPr lang="en-US" sz="6000" b="1" i="0">
                 <a:solidFill>
                   <a:srgbClr val="00B050"/>
                 </a:solidFill>
                 <a:effectLst/>
               </a:rPr>
-              <a:t>Adjacency Matrix</a:t>
+              <a:t>Adjacency List</a:t>
             </a:r>
             <a:endParaRPr lang="en-PH" dirty="0">
               <a:solidFill>
@@ -30548,13 +30353,13 @@
   <p:clrMapOvr>
     <a:masterClrMapping/>
   </p:clrMapOvr>
-  <mc:AlternateContent xmlns:mc="http://schemas.openxmlformats.org/markup-compatibility/2006">
-    <mc:Choice xmlns:p159="http://schemas.microsoft.com/office/powerpoint/2015/09/main" Requires="p159">
+  <mc:AlternateContent xmlns:mc="http://schemas.openxmlformats.org/markup-compatibility/2006" xmlns:p159="http://schemas.microsoft.com/office/powerpoint/2015/09/main">
+    <mc:Choice Requires="p159">
       <p:transition xmlns:p14="http://schemas.microsoft.com/office/powerpoint/2010/main" spd="slow" p14:dur="2000">
         <p159:morph option="byObject"/>
       </p:transition>
     </mc:Choice>
-    <mc:Fallback>
+    <mc:Fallback xmlns="">
       <p:transition spd="slow">
         <p:fade/>
       </p:transition>
@@ -34937,8 +34742,8 @@
           </a:fontRef>
         </p:style>
       </p:cxnSp>
-      <mc:AlternateContent xmlns:mc="http://schemas.openxmlformats.org/markup-compatibility/2006">
-        <mc:Choice xmlns:a14="http://schemas.microsoft.com/office/drawing/2010/main" Requires="a14">
+      <mc:AlternateContent xmlns:mc="http://schemas.openxmlformats.org/markup-compatibility/2006" xmlns:a14="http://schemas.microsoft.com/office/drawing/2010/main">
+        <mc:Choice Requires="a14">
           <p:sp>
             <p:nvSpPr>
               <p:cNvPr id="3" name="TextBox 2">
@@ -35045,7 +34850,7 @@
             </p:txBody>
           </p:sp>
         </mc:Choice>
-        <mc:Fallback>
+        <mc:Fallback xmlns="">
           <p:sp>
             <p:nvSpPr>
               <p:cNvPr id="3" name="TextBox 2">
@@ -35184,8 +34989,8 @@
           </a:p>
         </p:txBody>
       </p:sp>
-      <mc:AlternateContent xmlns:mc="http://schemas.openxmlformats.org/markup-compatibility/2006">
-        <mc:Choice xmlns:a14="http://schemas.microsoft.com/office/drawing/2010/main" Requires="a14">
+      <mc:AlternateContent xmlns:mc="http://schemas.openxmlformats.org/markup-compatibility/2006" xmlns:a14="http://schemas.microsoft.com/office/drawing/2010/main">
+        <mc:Choice Requires="a14">
           <p:sp>
             <p:nvSpPr>
               <p:cNvPr id="4" name="TextBox 3">
@@ -35322,7 +35127,7 @@
             </p:txBody>
           </p:sp>
         </mc:Choice>
-        <mc:Fallback>
+        <mc:Fallback xmlns="">
           <p:sp>
             <p:nvSpPr>
               <p:cNvPr id="4" name="TextBox 3">
@@ -35367,8 +35172,8 @@
           </p:sp>
         </mc:Fallback>
       </mc:AlternateContent>
-      <mc:AlternateContent xmlns:mc="http://schemas.openxmlformats.org/markup-compatibility/2006">
-        <mc:Choice xmlns:a14="http://schemas.microsoft.com/office/drawing/2010/main" Requires="a14">
+      <mc:AlternateContent xmlns:mc="http://schemas.openxmlformats.org/markup-compatibility/2006" xmlns:a14="http://schemas.microsoft.com/office/drawing/2010/main">
+        <mc:Choice Requires="a14">
           <p:sp>
             <p:nvSpPr>
               <p:cNvPr id="2" name="TextBox 1">
@@ -35475,7 +35280,7 @@
             </p:txBody>
           </p:sp>
         </mc:Choice>
-        <mc:Fallback>
+        <mc:Fallback xmlns="">
           <p:sp>
             <p:nvSpPr>
               <p:cNvPr id="2" name="TextBox 1">
@@ -36189,8 +35994,8 @@
           </a:p>
         </p:txBody>
       </p:sp>
-      <mc:AlternateContent xmlns:mc="http://schemas.openxmlformats.org/markup-compatibility/2006">
-        <mc:Choice xmlns:a14="http://schemas.microsoft.com/office/drawing/2010/main" Requires="a14">
+      <mc:AlternateContent xmlns:mc="http://schemas.openxmlformats.org/markup-compatibility/2006" xmlns:a14="http://schemas.microsoft.com/office/drawing/2010/main">
+        <mc:Choice Requires="a14">
           <p:sp>
             <p:nvSpPr>
               <p:cNvPr id="4" name="TextBox 3">
@@ -36335,7 +36140,7 @@
             </p:txBody>
           </p:sp>
         </mc:Choice>
-        <mc:Fallback>
+        <mc:Fallback xmlns="">
           <p:sp>
             <p:nvSpPr>
               <p:cNvPr id="4" name="TextBox 3">
@@ -36380,8 +36185,8 @@
           </p:sp>
         </mc:Fallback>
       </mc:AlternateContent>
-      <mc:AlternateContent xmlns:mc="http://schemas.openxmlformats.org/markup-compatibility/2006">
-        <mc:Choice xmlns:a14="http://schemas.microsoft.com/office/drawing/2010/main" Requires="a14">
+      <mc:AlternateContent xmlns:mc="http://schemas.openxmlformats.org/markup-compatibility/2006" xmlns:a14="http://schemas.microsoft.com/office/drawing/2010/main">
+        <mc:Choice Requires="a14">
           <p:sp>
             <p:nvSpPr>
               <p:cNvPr id="2" name="TextBox 1">
@@ -36542,7 +36347,7 @@
             </p:txBody>
           </p:sp>
         </mc:Choice>
-        <mc:Fallback>
+        <mc:Fallback xmlns="">
           <p:sp>
             <p:nvSpPr>
               <p:cNvPr id="2" name="TextBox 1">
@@ -37345,7 +37150,7 @@
             <p:spPr>
               <a:xfrm>
                 <a:off x="5974600" y="2218585"/>
-                <a:ext cx="4340644" cy="2400657"/>
+                <a:ext cx="4340644" cy="1938992"/>
               </a:xfrm>
               <a:prstGeom prst="rect">
                 <a:avLst/>
@@ -37574,74 +37379,15 @@
                         </a:rPr>
                         <m:t>,</m:t>
                       </m:r>
-                      <m:d>
-                        <m:dPr>
-                          <m:ctrlPr>
-                            <a:rPr lang="en-PH" sz="3000" i="1">
-                              <a:solidFill>
-                                <a:schemeClr val="bg1"/>
-                              </a:solidFill>
-                              <a:latin typeface="Cambria Math" panose="02040503050406030204" pitchFamily="18" charset="0"/>
-                            </a:rPr>
-                          </m:ctrlPr>
-                        </m:dPr>
-                        <m:e>
-                          <m:r>
-                            <a:rPr lang="en-PH" sz="3000" b="0" i="1" smtClean="0">
-                              <a:solidFill>
-                                <a:schemeClr val="bg1"/>
-                              </a:solidFill>
-                              <a:latin typeface="Cambria Math" panose="02040503050406030204" pitchFamily="18" charset="0"/>
-                            </a:rPr>
-                            <m:t>𝑏</m:t>
-                          </m:r>
-                          <m:r>
-                            <a:rPr lang="en-PH" sz="3000" i="1">
-                              <a:solidFill>
-                                <a:schemeClr val="bg1"/>
-                              </a:solidFill>
-                              <a:latin typeface="Cambria Math" panose="02040503050406030204" pitchFamily="18" charset="0"/>
-                            </a:rPr>
-                            <m:t>,</m:t>
-                          </m:r>
-                          <m:r>
-                            <a:rPr lang="en-PH" sz="3000" b="0" i="1" smtClean="0">
-                              <a:solidFill>
-                                <a:schemeClr val="bg1"/>
-                              </a:solidFill>
-                              <a:latin typeface="Cambria Math" panose="02040503050406030204" pitchFamily="18" charset="0"/>
-                            </a:rPr>
-                            <m:t>𝑒</m:t>
-                          </m:r>
-                        </m:e>
-                      </m:d>
                       <m:r>
-                        <a:rPr lang="en-PH" sz="3000" i="1">
+                        <a:rPr lang="en-PH" sz="3000" i="1" smtClean="0">
                           <a:solidFill>
                             <a:schemeClr val="bg1"/>
                           </a:solidFill>
                           <a:latin typeface="Cambria Math" panose="02040503050406030204" pitchFamily="18" charset="0"/>
                         </a:rPr>
-                        <m:t>,</m:t>
+                        <m:t> </m:t>
                       </m:r>
-                    </m:oMath>
-                  </m:oMathPara>
-                </a14:m>
-                <a:endParaRPr lang="en-PH" sz="3000" i="1" dirty="0">
-                  <a:solidFill>
-                    <a:schemeClr val="bg1"/>
-                  </a:solidFill>
-                  <a:latin typeface="Cambria Math" panose="02040503050406030204" pitchFamily="18" charset="0"/>
-                </a:endParaRPr>
-              </a:p>
-              <a:p>
-                <a:pPr/>
-                <a14:m>
-                  <m:oMathPara xmlns:m="http://schemas.openxmlformats.org/officeDocument/2006/math">
-                    <m:oMathParaPr>
-                      <m:jc m:val="centerGroup"/>
-                    </m:oMathParaPr>
-                    <m:oMath xmlns:m="http://schemas.openxmlformats.org/officeDocument/2006/math">
                       <m:d>
                         <m:dPr>
                           <m:ctrlPr>
@@ -37849,7 +37595,7 @@
             <p:spPr>
               <a:xfrm>
                 <a:off x="5974600" y="2218585"/>
-                <a:ext cx="4340644" cy="2400657"/>
+                <a:ext cx="4340644" cy="1938992"/>
               </a:xfrm>
               <a:prstGeom prst="rect">
                 <a:avLst/>
@@ -39811,18 +39557,18 @@
 </file>
 
 <file path=customXml/item2.xml><?xml version="1.0" encoding="utf-8"?>
-<p:properties xmlns:p="http://schemas.microsoft.com/office/2006/metadata/properties" xmlns:xsi="http://www.w3.org/2001/XMLSchema-instance" xmlns:pc="http://schemas.microsoft.com/office/infopath/2007/PartnerControls">
-  <documentManagement/>
-</p:properties>
-</file>
-
-<file path=customXml/item3.xml><?xml version="1.0" encoding="utf-8"?>
 <?mso-contentType ?>
 <FormTemplates xmlns="http://schemas.microsoft.com/sharepoint/v3/contenttype/forms">
   <Display>DocumentLibraryForm</Display>
   <Edit>DocumentLibraryForm</Edit>
   <New>DocumentLibraryForm</New>
 </FormTemplates>
+</file>
+
+<file path=customXml/item3.xml><?xml version="1.0" encoding="utf-8"?>
+<p:properties xmlns:p="http://schemas.microsoft.com/office/2006/metadata/properties" xmlns:xsi="http://www.w3.org/2001/XMLSchema-instance" xmlns:pc="http://schemas.microsoft.com/office/infopath/2007/PartnerControls">
+  <documentManagement/>
+</p:properties>
 </file>
 
 <file path=customXml/itemProps1.xml><?xml version="1.0" encoding="utf-8"?>
@@ -39844,18 +39590,18 @@
 </file>
 
 <file path=customXml/itemProps2.xml><?xml version="1.0" encoding="utf-8"?>
+<ds:datastoreItem xmlns:ds="http://schemas.openxmlformats.org/officeDocument/2006/customXml" ds:itemID="{C598EE6F-E26B-42BB-A8C4-ECA40997D302}">
+  <ds:schemaRefs>
+    <ds:schemaRef ds:uri="http://schemas.microsoft.com/sharepoint/v3/contenttype/forms"/>
+  </ds:schemaRefs>
+</ds:datastoreItem>
+</file>
+
+<file path=customXml/itemProps3.xml><?xml version="1.0" encoding="utf-8"?>
 <ds:datastoreItem xmlns:ds="http://schemas.openxmlformats.org/officeDocument/2006/customXml" ds:itemID="{857C6131-C561-4201-AE06-D21CDE528BF4}">
   <ds:schemaRefs>
     <ds:schemaRef ds:uri="http://schemas.microsoft.com/office/2006/metadata/properties"/>
     <ds:schemaRef ds:uri="http://schemas.microsoft.com/office/infopath/2007/PartnerControls"/>
   </ds:schemaRefs>
 </ds:datastoreItem>
-</file>
-
-<file path=customXml/itemProps3.xml><?xml version="1.0" encoding="utf-8"?>
-<ds:datastoreItem xmlns:ds="http://schemas.openxmlformats.org/officeDocument/2006/customXml" ds:itemID="{C598EE6F-E26B-42BB-A8C4-ECA40997D302}">
-  <ds:schemaRefs>
-    <ds:schemaRef ds:uri="http://schemas.microsoft.com/sharepoint/v3/contenttype/forms"/>
-  </ds:schemaRefs>
-</ds:datastoreItem>
 </file>
</xml_diff>